<commit_message>
fix: resolve pitch deck review issues - rewrite design-partner, enterprise, regional, gamma copy; rebuild PDFs; sync to public
</commit_message>
<xml_diff>
--- a/docs/pitch-decks/design-partner/pptx/26-real-estate.pptx
+++ b/docs/pitch-decks/design-partner/pptx/26-real-estate.pptx
@@ -1765,7 +1765,7 @@
                   <a:srgbClr val="8B8FA3"/>
                 </a:solidFill>
               </a:rPr>
-              <a:t>Clinical decision support with HIPAA-compliant audit trails</a:t>
+              <a:t>Auditable AI workflows for Real Estate / Construction</a:t>
             </a:r>
             <a:endParaRPr lang="en-US" sz="1200" dirty="0"/>
           </a:p>
@@ -1995,7 +1995,7 @@
                   <a:srgbClr val="FFFFFF"/>
                 </a:solidFill>
               </a:rPr>
-              <a:t>"Real Estate / Construction AI has no accountability layer. Clinical decisions need explainable, auditable AI — with patient safety as the prime directive."</a:t>
+              <a:t>"Real Estate / Construction teams are bringing AI into high-stakes workflows. They need evidence, dissent, and accountable approvals — not unexplained outputs."</a:t>
             </a:r>
             <a:endParaRPr lang="en-US" sz="2200" dirty="0"/>
           </a:p>
@@ -2715,7 +2715,7 @@
                   <a:srgbClr val="8B8FA3"/>
                 </a:solidFill>
               </a:rPr>
-              <a:t>Clinical systems integration and health informatics</a:t>
+              <a:t>Real Estate / Construction workflow oversight and escalation review</a:t>
             </a:r>
             <a:endParaRPr lang="en-US" sz="1200" dirty="0"/>
           </a:p>
@@ -2733,7 +2733,7 @@
                   <a:srgbClr val="8B8FA3"/>
                 </a:solidFill>
               </a:rPr>
-              <a:t>Safety metrics, adverse event prevention</a:t>
+              <a:t>Risk, exception, and approval tracking across teams</a:t>
             </a:r>
             <a:endParaRPr lang="en-US" sz="1200" dirty="0"/>
           </a:p>
@@ -2751,7 +2751,7 @@
                   <a:srgbClr val="8B8FA3"/>
                 </a:solidFill>
               </a:rPr>
-              <a:t>HIPAA, FDA, CMS regulatory compliance</a:t>
+              <a:t>Exportable evidence for internal, customer, and regulator review</a:t>
             </a:r>
             <a:endParaRPr lang="en-US" sz="1200" dirty="0"/>
           </a:p>
@@ -3039,7 +3039,7 @@
                   <a:srgbClr val="8B8FA3"/>
                 </a:solidFill>
               </a:rPr>
-              <a:t>Clinical protocol review — Multi-agent evaluation against safety, regulatory, and financial criteria</a:t>
+              <a:t>Real Estate / Construction policy and exception review with multi-agent deliberation</a:t>
             </a:r>
             <a:endParaRPr lang="en-US" sz="1200" dirty="0"/>
           </a:p>
@@ -3057,7 +3057,7 @@
                   <a:srgbClr val="8B8FA3"/>
                 </a:solidFill>
               </a:rPr>
-              <a:t>Hospital M&amp;A due diligence — Clinical outcomes, compliance, financial health analysis</a:t>
+              <a:t>Vendor, partner, or procurement evaluation with full evidence trail</a:t>
             </a:r>
             <a:endParaRPr lang="en-US" sz="1200" dirty="0"/>
           </a:p>
@@ -3075,7 +3075,7 @@
                   <a:srgbClr val="8B8FA3"/>
                 </a:solidFill>
               </a:rPr>
-              <a:t>Regulatory change impact — CMS/FDA guidance mapped across operations</a:t>
+              <a:t>Incident replay and root-cause analysis with preserved dissent</a:t>
             </a:r>
             <a:endParaRPr lang="en-US" sz="1200" dirty="0"/>
           </a:p>
@@ -3093,7 +3093,7 @@
                   <a:srgbClr val="8B8FA3"/>
                 </a:solidFill>
               </a:rPr>
-              <a:t>Patient safety incident review — Full decision replay with evidence preservation</a:t>
+              <a:t>Budget and priority setting with accountable approvals</a:t>
             </a:r>
             <a:endParaRPr lang="en-US" sz="1200" dirty="0"/>
           </a:p>
@@ -3111,7 +3111,7 @@
                   <a:srgbClr val="8B8FA3"/>
                 </a:solidFill>
               </a:rPr>
-              <a:t>Value-based care optimization — Balance quality, outcomes, and financial sustainability</a:t>
+              <a:t>Stakeholder reporting from one searchable decision record</a:t>
             </a:r>
             <a:endParaRPr lang="en-US" sz="1200" dirty="0"/>
           </a:p>

</xml_diff>